<commit_message>
Update samples and README - 2026-10-01 09:49 UTC
</commit_message>
<xml_diff>
--- a/samples/test_pptx.pptx
+++ b/samples/test_pptx.pptx
@@ -129,7 +129,7 @@
           <p:cNvPr id="2" name="Title 1">
             <a:extLst>
               <a:ext uri="{FF2B5EF4-FFF2-40B4-BE49-F238E27FC236}">
-                <a16:creationId xmlns:a16="http://schemas.microsoft.com/office/drawing/2014/main" id="{B9721617-4036-706C-F69F-3665592C4064}"/>
+                <a16:creationId xmlns:a16="http://schemas.microsoft.com/office/drawing/2014/main" id="{46F398A3-F2D5-0301-895D-2F1B1CC9C754}"/>
               </a:ext>
             </a:extLst>
           </p:cNvPr>
@@ -166,7 +166,7 @@
           <p:cNvPr id="3" name="Subtitle 2">
             <a:extLst>
               <a:ext uri="{FF2B5EF4-FFF2-40B4-BE49-F238E27FC236}">
-                <a16:creationId xmlns:a16="http://schemas.microsoft.com/office/drawing/2014/main" id="{9F51769B-01BD-FE44-1ABD-0E528FD1FDF3}"/>
+                <a16:creationId xmlns:a16="http://schemas.microsoft.com/office/drawing/2014/main" id="{6EDA54E5-E7A5-24DD-33B2-2B398DAF69FB}"/>
               </a:ext>
             </a:extLst>
           </p:cNvPr>
@@ -236,7 +236,7 @@
           <p:cNvPr id="4" name="Date Placeholder 3">
             <a:extLst>
               <a:ext uri="{FF2B5EF4-FFF2-40B4-BE49-F238E27FC236}">
-                <a16:creationId xmlns:a16="http://schemas.microsoft.com/office/drawing/2014/main" id="{F5D17369-4F7E-3C12-7544-9A0A093C820F}"/>
+                <a16:creationId xmlns:a16="http://schemas.microsoft.com/office/drawing/2014/main" id="{6EE89C28-9F4C-D0D5-0D1D-7DF53E7DF5C2}"/>
               </a:ext>
             </a:extLst>
           </p:cNvPr>
@@ -252,9 +252,9 @@
           <a:bodyPr/>
           <a:lstStyle/>
           <a:p>
-            <a:fld id="{CBFBF2EA-DCA5-4BA8-BC03-B27E08876126}" type="datetimeFigureOut">
+            <a:fld id="{1211C29D-6992-4A5E-810C-59ADE211F8AC}" type="datetimeFigureOut">
               <a:rPr lang="en-US" smtClean="0"/>
-              <a:t>5/17/2026</a:t>
+              <a:t>8/26/2026</a:t>
             </a:fld>
             <a:endParaRPr lang="en-US"/>
           </a:p>
@@ -265,7 +265,7 @@
           <p:cNvPr id="5" name="Footer Placeholder 4">
             <a:extLst>
               <a:ext uri="{FF2B5EF4-FFF2-40B4-BE49-F238E27FC236}">
-                <a16:creationId xmlns:a16="http://schemas.microsoft.com/office/drawing/2014/main" id="{F24DCBC4-2D0C-0BB9-17E2-234FFA5CAAE5}"/>
+                <a16:creationId xmlns:a16="http://schemas.microsoft.com/office/drawing/2014/main" id="{D53C8CF4-68FA-F8B0-1233-B733C796F157}"/>
               </a:ext>
             </a:extLst>
           </p:cNvPr>
@@ -290,7 +290,7 @@
           <p:cNvPr id="6" name="Slide Number Placeholder 5">
             <a:extLst>
               <a:ext uri="{FF2B5EF4-FFF2-40B4-BE49-F238E27FC236}">
-                <a16:creationId xmlns:a16="http://schemas.microsoft.com/office/drawing/2014/main" id="{532C8A76-1A28-CB01-AC6E-C1AE94949C36}"/>
+                <a16:creationId xmlns:a16="http://schemas.microsoft.com/office/drawing/2014/main" id="{D8AF55F7-598C-7B76-4008-F49BDCBC1BF0}"/>
               </a:ext>
             </a:extLst>
           </p:cNvPr>
@@ -306,7 +306,7 @@
           <a:bodyPr/>
           <a:lstStyle/>
           <a:p>
-            <a:fld id="{3627C499-8D20-466E-8BD2-CC7391BCFA86}" type="slidenum">
+            <a:fld id="{BCBB5E3D-8ABD-442F-B7FD-8616974D6634}" type="slidenum">
               <a:rPr lang="en-US" smtClean="0"/>
               <a:t>‹#›</a:t>
             </a:fld>
@@ -317,7 +317,7 @@
     </p:spTree>
     <p:extLst>
       <p:ext uri="{BB962C8B-B14F-4D97-AF65-F5344CB8AC3E}">
-        <p14:creationId xmlns:p14="http://schemas.microsoft.com/office/powerpoint/2010/main" val="2258664607"/>
+        <p14:creationId xmlns:p14="http://schemas.microsoft.com/office/powerpoint/2010/main" val="967094481"/>
       </p:ext>
     </p:extLst>
   </p:cSld>
@@ -349,7 +349,7 @@
           <p:cNvPr id="2" name="Title 1">
             <a:extLst>
               <a:ext uri="{FF2B5EF4-FFF2-40B4-BE49-F238E27FC236}">
-                <a16:creationId xmlns:a16="http://schemas.microsoft.com/office/drawing/2014/main" id="{5E17F16D-7C21-90C1-7A33-4EFCEE120236}"/>
+                <a16:creationId xmlns:a16="http://schemas.microsoft.com/office/drawing/2014/main" id="{15B45A26-FA1A-596B-49B1-9B6A585EE1CD}"/>
               </a:ext>
             </a:extLst>
           </p:cNvPr>
@@ -377,7 +377,7 @@
           <p:cNvPr id="3" name="Vertical Text Placeholder 2">
             <a:extLst>
               <a:ext uri="{FF2B5EF4-FFF2-40B4-BE49-F238E27FC236}">
-                <a16:creationId xmlns:a16="http://schemas.microsoft.com/office/drawing/2014/main" id="{BD93DF4C-27B0-0C40-B65A-1CEB6E1D7AFA}"/>
+                <a16:creationId xmlns:a16="http://schemas.microsoft.com/office/drawing/2014/main" id="{CD59351F-1836-A94D-88AF-B0BD3BF51A08}"/>
               </a:ext>
             </a:extLst>
           </p:cNvPr>
@@ -434,7 +434,7 @@
           <p:cNvPr id="4" name="Date Placeholder 3">
             <a:extLst>
               <a:ext uri="{FF2B5EF4-FFF2-40B4-BE49-F238E27FC236}">
-                <a16:creationId xmlns:a16="http://schemas.microsoft.com/office/drawing/2014/main" id="{CAC06E6E-5C8D-7346-4EA5-ED0DFFE2C56B}"/>
+                <a16:creationId xmlns:a16="http://schemas.microsoft.com/office/drawing/2014/main" id="{435EDD8C-64C9-A662-12D9-4FE96A442457}"/>
               </a:ext>
             </a:extLst>
           </p:cNvPr>
@@ -450,9 +450,9 @@
           <a:bodyPr/>
           <a:lstStyle/>
           <a:p>
-            <a:fld id="{CBFBF2EA-DCA5-4BA8-BC03-B27E08876126}" type="datetimeFigureOut">
+            <a:fld id="{1211C29D-6992-4A5E-810C-59ADE211F8AC}" type="datetimeFigureOut">
               <a:rPr lang="en-US" smtClean="0"/>
-              <a:t>5/17/2026</a:t>
+              <a:t>8/26/2026</a:t>
             </a:fld>
             <a:endParaRPr lang="en-US"/>
           </a:p>
@@ -463,7 +463,7 @@
           <p:cNvPr id="5" name="Footer Placeholder 4">
             <a:extLst>
               <a:ext uri="{FF2B5EF4-FFF2-40B4-BE49-F238E27FC236}">
-                <a16:creationId xmlns:a16="http://schemas.microsoft.com/office/drawing/2014/main" id="{53260391-AD69-FDB8-3FC9-6C1A1CD04863}"/>
+                <a16:creationId xmlns:a16="http://schemas.microsoft.com/office/drawing/2014/main" id="{FF933DE7-150F-99EF-FA9A-9A6F4DBE3D9C}"/>
               </a:ext>
             </a:extLst>
           </p:cNvPr>
@@ -488,7 +488,7 @@
           <p:cNvPr id="6" name="Slide Number Placeholder 5">
             <a:extLst>
               <a:ext uri="{FF2B5EF4-FFF2-40B4-BE49-F238E27FC236}">
-                <a16:creationId xmlns:a16="http://schemas.microsoft.com/office/drawing/2014/main" id="{8C42B3E2-5521-312D-4471-33AF92BFA23F}"/>
+                <a16:creationId xmlns:a16="http://schemas.microsoft.com/office/drawing/2014/main" id="{55EF3898-6374-676A-52F8-C6C1ED006B66}"/>
               </a:ext>
             </a:extLst>
           </p:cNvPr>
@@ -504,7 +504,7 @@
           <a:bodyPr/>
           <a:lstStyle/>
           <a:p>
-            <a:fld id="{3627C499-8D20-466E-8BD2-CC7391BCFA86}" type="slidenum">
+            <a:fld id="{BCBB5E3D-8ABD-442F-B7FD-8616974D6634}" type="slidenum">
               <a:rPr lang="en-US" smtClean="0"/>
               <a:t>‹#›</a:t>
             </a:fld>
@@ -515,7 +515,7 @@
     </p:spTree>
     <p:extLst>
       <p:ext uri="{BB962C8B-B14F-4D97-AF65-F5344CB8AC3E}">
-        <p14:creationId xmlns:p14="http://schemas.microsoft.com/office/powerpoint/2010/main" val="1393055715"/>
+        <p14:creationId xmlns:p14="http://schemas.microsoft.com/office/powerpoint/2010/main" val="3325938728"/>
       </p:ext>
     </p:extLst>
   </p:cSld>
@@ -547,7 +547,7 @@
           <p:cNvPr id="2" name="Vertical Title 1">
             <a:extLst>
               <a:ext uri="{FF2B5EF4-FFF2-40B4-BE49-F238E27FC236}">
-                <a16:creationId xmlns:a16="http://schemas.microsoft.com/office/drawing/2014/main" id="{B00EF7E1-92CE-6915-3EAB-AF5DDDC1513F}"/>
+                <a16:creationId xmlns:a16="http://schemas.microsoft.com/office/drawing/2014/main" id="{001A3598-89D7-82CE-99A3-19F1F1C0CB6E}"/>
               </a:ext>
             </a:extLst>
           </p:cNvPr>
@@ -580,7 +580,7 @@
           <p:cNvPr id="3" name="Vertical Text Placeholder 2">
             <a:extLst>
               <a:ext uri="{FF2B5EF4-FFF2-40B4-BE49-F238E27FC236}">
-                <a16:creationId xmlns:a16="http://schemas.microsoft.com/office/drawing/2014/main" id="{4C8DDA5D-9F1F-8533-E62D-61AE7DD4152D}"/>
+                <a16:creationId xmlns:a16="http://schemas.microsoft.com/office/drawing/2014/main" id="{AB8B0D18-6884-19D6-7DCE-08487886D0C8}"/>
               </a:ext>
             </a:extLst>
           </p:cNvPr>
@@ -642,7 +642,7 @@
           <p:cNvPr id="4" name="Date Placeholder 3">
             <a:extLst>
               <a:ext uri="{FF2B5EF4-FFF2-40B4-BE49-F238E27FC236}">
-                <a16:creationId xmlns:a16="http://schemas.microsoft.com/office/drawing/2014/main" id="{53CB14F1-7043-4853-2443-3A60E54039C8}"/>
+                <a16:creationId xmlns:a16="http://schemas.microsoft.com/office/drawing/2014/main" id="{06FC0F1E-2498-E8B3-786D-31FD7038671D}"/>
               </a:ext>
             </a:extLst>
           </p:cNvPr>
@@ -658,9 +658,9 @@
           <a:bodyPr/>
           <a:lstStyle/>
           <a:p>
-            <a:fld id="{CBFBF2EA-DCA5-4BA8-BC03-B27E08876126}" type="datetimeFigureOut">
+            <a:fld id="{1211C29D-6992-4A5E-810C-59ADE211F8AC}" type="datetimeFigureOut">
               <a:rPr lang="en-US" smtClean="0"/>
-              <a:t>5/17/2026</a:t>
+              <a:t>8/26/2026</a:t>
             </a:fld>
             <a:endParaRPr lang="en-US"/>
           </a:p>
@@ -671,7 +671,7 @@
           <p:cNvPr id="5" name="Footer Placeholder 4">
             <a:extLst>
               <a:ext uri="{FF2B5EF4-FFF2-40B4-BE49-F238E27FC236}">
-                <a16:creationId xmlns:a16="http://schemas.microsoft.com/office/drawing/2014/main" id="{13FD9703-0AAE-33DF-A00D-38989A3B3DCB}"/>
+                <a16:creationId xmlns:a16="http://schemas.microsoft.com/office/drawing/2014/main" id="{D3092F0D-A0A0-C43E-4675-F87953BB82BE}"/>
               </a:ext>
             </a:extLst>
           </p:cNvPr>
@@ -696,7 +696,7 @@
           <p:cNvPr id="6" name="Slide Number Placeholder 5">
             <a:extLst>
               <a:ext uri="{FF2B5EF4-FFF2-40B4-BE49-F238E27FC236}">
-                <a16:creationId xmlns:a16="http://schemas.microsoft.com/office/drawing/2014/main" id="{80747893-8718-6F2F-DED8-D31505C07370}"/>
+                <a16:creationId xmlns:a16="http://schemas.microsoft.com/office/drawing/2014/main" id="{3351A47B-D70E-A204-2E75-AB31AD79FD7F}"/>
               </a:ext>
             </a:extLst>
           </p:cNvPr>
@@ -712,7 +712,7 @@
           <a:bodyPr/>
           <a:lstStyle/>
           <a:p>
-            <a:fld id="{3627C499-8D20-466E-8BD2-CC7391BCFA86}" type="slidenum">
+            <a:fld id="{BCBB5E3D-8ABD-442F-B7FD-8616974D6634}" type="slidenum">
               <a:rPr lang="en-US" smtClean="0"/>
               <a:t>‹#›</a:t>
             </a:fld>
@@ -723,7 +723,7 @@
     </p:spTree>
     <p:extLst>
       <p:ext uri="{BB962C8B-B14F-4D97-AF65-F5344CB8AC3E}">
-        <p14:creationId xmlns:p14="http://schemas.microsoft.com/office/powerpoint/2010/main" val="2943776124"/>
+        <p14:creationId xmlns:p14="http://schemas.microsoft.com/office/powerpoint/2010/main" val="1722068755"/>
       </p:ext>
     </p:extLst>
   </p:cSld>
@@ -755,7 +755,7 @@
           <p:cNvPr id="2" name="Title 1">
             <a:extLst>
               <a:ext uri="{FF2B5EF4-FFF2-40B4-BE49-F238E27FC236}">
-                <a16:creationId xmlns:a16="http://schemas.microsoft.com/office/drawing/2014/main" id="{9EA43F71-20BE-5EB2-8E1A-59D060800ADA}"/>
+                <a16:creationId xmlns:a16="http://schemas.microsoft.com/office/drawing/2014/main" id="{C78C79A3-E9AC-F006-E435-B47D66BFC16F}"/>
               </a:ext>
             </a:extLst>
           </p:cNvPr>
@@ -783,7 +783,7 @@
           <p:cNvPr id="3" name="Content Placeholder 2">
             <a:extLst>
               <a:ext uri="{FF2B5EF4-FFF2-40B4-BE49-F238E27FC236}">
-                <a16:creationId xmlns:a16="http://schemas.microsoft.com/office/drawing/2014/main" id="{B4365EF4-2D5E-5CCF-31CD-DB59F3AF837E}"/>
+                <a16:creationId xmlns:a16="http://schemas.microsoft.com/office/drawing/2014/main" id="{94BA14DB-F0C9-17B2-3BB3-B79052955F4C}"/>
               </a:ext>
             </a:extLst>
           </p:cNvPr>
@@ -840,7 +840,7 @@
           <p:cNvPr id="4" name="Date Placeholder 3">
             <a:extLst>
               <a:ext uri="{FF2B5EF4-FFF2-40B4-BE49-F238E27FC236}">
-                <a16:creationId xmlns:a16="http://schemas.microsoft.com/office/drawing/2014/main" id="{F9C3BB02-3DA7-8099-7471-3E6E66A775D5}"/>
+                <a16:creationId xmlns:a16="http://schemas.microsoft.com/office/drawing/2014/main" id="{E1E8927C-BF85-95B8-B926-9F545F29D753}"/>
               </a:ext>
             </a:extLst>
           </p:cNvPr>
@@ -856,9 +856,9 @@
           <a:bodyPr/>
           <a:lstStyle/>
           <a:p>
-            <a:fld id="{CBFBF2EA-DCA5-4BA8-BC03-B27E08876126}" type="datetimeFigureOut">
+            <a:fld id="{1211C29D-6992-4A5E-810C-59ADE211F8AC}" type="datetimeFigureOut">
               <a:rPr lang="en-US" smtClean="0"/>
-              <a:t>5/17/2026</a:t>
+              <a:t>8/26/2026</a:t>
             </a:fld>
             <a:endParaRPr lang="en-US"/>
           </a:p>
@@ -869,7 +869,7 @@
           <p:cNvPr id="5" name="Footer Placeholder 4">
             <a:extLst>
               <a:ext uri="{FF2B5EF4-FFF2-40B4-BE49-F238E27FC236}">
-                <a16:creationId xmlns:a16="http://schemas.microsoft.com/office/drawing/2014/main" id="{7BF2FBBC-D567-E021-FCDB-9350331BA369}"/>
+                <a16:creationId xmlns:a16="http://schemas.microsoft.com/office/drawing/2014/main" id="{93F08D07-34A0-752E-68EC-ADB6838E8721}"/>
               </a:ext>
             </a:extLst>
           </p:cNvPr>
@@ -894,7 +894,7 @@
           <p:cNvPr id="6" name="Slide Number Placeholder 5">
             <a:extLst>
               <a:ext uri="{FF2B5EF4-FFF2-40B4-BE49-F238E27FC236}">
-                <a16:creationId xmlns:a16="http://schemas.microsoft.com/office/drawing/2014/main" id="{FB505438-91B9-C0AA-5071-43FDF38C128B}"/>
+                <a16:creationId xmlns:a16="http://schemas.microsoft.com/office/drawing/2014/main" id="{86B89D2D-EF58-3A8C-4492-DD8ECC22E61B}"/>
               </a:ext>
             </a:extLst>
           </p:cNvPr>
@@ -910,7 +910,7 @@
           <a:bodyPr/>
           <a:lstStyle/>
           <a:p>
-            <a:fld id="{3627C499-8D20-466E-8BD2-CC7391BCFA86}" type="slidenum">
+            <a:fld id="{BCBB5E3D-8ABD-442F-B7FD-8616974D6634}" type="slidenum">
               <a:rPr lang="en-US" smtClean="0"/>
               <a:t>‹#›</a:t>
             </a:fld>
@@ -921,7 +921,7 @@
     </p:spTree>
     <p:extLst>
       <p:ext uri="{BB962C8B-B14F-4D97-AF65-F5344CB8AC3E}">
-        <p14:creationId xmlns:p14="http://schemas.microsoft.com/office/powerpoint/2010/main" val="3310149106"/>
+        <p14:creationId xmlns:p14="http://schemas.microsoft.com/office/powerpoint/2010/main" val="2923123873"/>
       </p:ext>
     </p:extLst>
   </p:cSld>
@@ -953,7 +953,7 @@
           <p:cNvPr id="2" name="Title 1">
             <a:extLst>
               <a:ext uri="{FF2B5EF4-FFF2-40B4-BE49-F238E27FC236}">
-                <a16:creationId xmlns:a16="http://schemas.microsoft.com/office/drawing/2014/main" id="{BCEE7303-4E59-9D77-F7FD-DB9F694C8AEA}"/>
+                <a16:creationId xmlns:a16="http://schemas.microsoft.com/office/drawing/2014/main" id="{36DCD9B2-B013-F506-23B1-66818FCDBD41}"/>
               </a:ext>
             </a:extLst>
           </p:cNvPr>
@@ -990,7 +990,7 @@
           <p:cNvPr id="3" name="Text Placeholder 2">
             <a:extLst>
               <a:ext uri="{FF2B5EF4-FFF2-40B4-BE49-F238E27FC236}">
-                <a16:creationId xmlns:a16="http://schemas.microsoft.com/office/drawing/2014/main" id="{972E64FE-3959-3A5F-E3F0-64AC151D7713}"/>
+                <a16:creationId xmlns:a16="http://schemas.microsoft.com/office/drawing/2014/main" id="{58CCF6A8-64CE-B261-7753-024941D3CC79}"/>
               </a:ext>
             </a:extLst>
           </p:cNvPr>
@@ -1115,7 +1115,7 @@
           <p:cNvPr id="4" name="Date Placeholder 3">
             <a:extLst>
               <a:ext uri="{FF2B5EF4-FFF2-40B4-BE49-F238E27FC236}">
-                <a16:creationId xmlns:a16="http://schemas.microsoft.com/office/drawing/2014/main" id="{D11045A4-A6A1-54A2-08BF-2801885775C3}"/>
+                <a16:creationId xmlns:a16="http://schemas.microsoft.com/office/drawing/2014/main" id="{6D231D0D-0108-2663-E485-33CA0ACB0AE1}"/>
               </a:ext>
             </a:extLst>
           </p:cNvPr>
@@ -1131,9 +1131,9 @@
           <a:bodyPr/>
           <a:lstStyle/>
           <a:p>
-            <a:fld id="{CBFBF2EA-DCA5-4BA8-BC03-B27E08876126}" type="datetimeFigureOut">
+            <a:fld id="{1211C29D-6992-4A5E-810C-59ADE211F8AC}" type="datetimeFigureOut">
               <a:rPr lang="en-US" smtClean="0"/>
-              <a:t>5/17/2026</a:t>
+              <a:t>8/26/2026</a:t>
             </a:fld>
             <a:endParaRPr lang="en-US"/>
           </a:p>
@@ -1144,7 +1144,7 @@
           <p:cNvPr id="5" name="Footer Placeholder 4">
             <a:extLst>
               <a:ext uri="{FF2B5EF4-FFF2-40B4-BE49-F238E27FC236}">
-                <a16:creationId xmlns:a16="http://schemas.microsoft.com/office/drawing/2014/main" id="{FD501E63-C3B2-F360-F287-14082ACDAB56}"/>
+                <a16:creationId xmlns:a16="http://schemas.microsoft.com/office/drawing/2014/main" id="{B8242C1E-B7D3-B7AD-196A-67FCF4DD7F94}"/>
               </a:ext>
             </a:extLst>
           </p:cNvPr>
@@ -1169,7 +1169,7 @@
           <p:cNvPr id="6" name="Slide Number Placeholder 5">
             <a:extLst>
               <a:ext uri="{FF2B5EF4-FFF2-40B4-BE49-F238E27FC236}">
-                <a16:creationId xmlns:a16="http://schemas.microsoft.com/office/drawing/2014/main" id="{2D70D851-FE86-8506-361D-D9A957AD6722}"/>
+                <a16:creationId xmlns:a16="http://schemas.microsoft.com/office/drawing/2014/main" id="{A6518A39-4812-A060-B3A1-344710C73942}"/>
               </a:ext>
             </a:extLst>
           </p:cNvPr>
@@ -1185,7 +1185,7 @@
           <a:bodyPr/>
           <a:lstStyle/>
           <a:p>
-            <a:fld id="{3627C499-8D20-466E-8BD2-CC7391BCFA86}" type="slidenum">
+            <a:fld id="{BCBB5E3D-8ABD-442F-B7FD-8616974D6634}" type="slidenum">
               <a:rPr lang="en-US" smtClean="0"/>
               <a:t>‹#›</a:t>
             </a:fld>
@@ -1196,7 +1196,7 @@
     </p:spTree>
     <p:extLst>
       <p:ext uri="{BB962C8B-B14F-4D97-AF65-F5344CB8AC3E}">
-        <p14:creationId xmlns:p14="http://schemas.microsoft.com/office/powerpoint/2010/main" val="631197965"/>
+        <p14:creationId xmlns:p14="http://schemas.microsoft.com/office/powerpoint/2010/main" val="1663904140"/>
       </p:ext>
     </p:extLst>
   </p:cSld>
@@ -1228,7 +1228,7 @@
           <p:cNvPr id="2" name="Title 1">
             <a:extLst>
               <a:ext uri="{FF2B5EF4-FFF2-40B4-BE49-F238E27FC236}">
-                <a16:creationId xmlns:a16="http://schemas.microsoft.com/office/drawing/2014/main" id="{189BE50C-5A6D-6B25-512E-0A315FB0E2BE}"/>
+                <a16:creationId xmlns:a16="http://schemas.microsoft.com/office/drawing/2014/main" id="{7099EAEB-F232-FAE2-4A53-AE50570F22F5}"/>
               </a:ext>
             </a:extLst>
           </p:cNvPr>
@@ -1256,7 +1256,7 @@
           <p:cNvPr id="3" name="Content Placeholder 2">
             <a:extLst>
               <a:ext uri="{FF2B5EF4-FFF2-40B4-BE49-F238E27FC236}">
-                <a16:creationId xmlns:a16="http://schemas.microsoft.com/office/drawing/2014/main" id="{59499F62-8AC3-46DD-1D91-B45D8DD32FC1}"/>
+                <a16:creationId xmlns:a16="http://schemas.microsoft.com/office/drawing/2014/main" id="{DC61478E-8259-B2EB-5E81-913638B38EDD}"/>
               </a:ext>
             </a:extLst>
           </p:cNvPr>
@@ -1318,7 +1318,7 @@
           <p:cNvPr id="4" name="Content Placeholder 3">
             <a:extLst>
               <a:ext uri="{FF2B5EF4-FFF2-40B4-BE49-F238E27FC236}">
-                <a16:creationId xmlns:a16="http://schemas.microsoft.com/office/drawing/2014/main" id="{FF63AC58-409D-3782-E8E4-E4BE83842EA8}"/>
+                <a16:creationId xmlns:a16="http://schemas.microsoft.com/office/drawing/2014/main" id="{87F7A78E-A3C4-261A-6669-CE72D0E60FA0}"/>
               </a:ext>
             </a:extLst>
           </p:cNvPr>
@@ -1380,7 +1380,7 @@
           <p:cNvPr id="5" name="Date Placeholder 4">
             <a:extLst>
               <a:ext uri="{FF2B5EF4-FFF2-40B4-BE49-F238E27FC236}">
-                <a16:creationId xmlns:a16="http://schemas.microsoft.com/office/drawing/2014/main" id="{F4F1BA71-2244-061B-5DB2-BBB2B6800A6A}"/>
+                <a16:creationId xmlns:a16="http://schemas.microsoft.com/office/drawing/2014/main" id="{52D697FF-AA99-C0CA-C574-58D7F54DFCAC}"/>
               </a:ext>
             </a:extLst>
           </p:cNvPr>
@@ -1396,9 +1396,9 @@
           <a:bodyPr/>
           <a:lstStyle/>
           <a:p>
-            <a:fld id="{CBFBF2EA-DCA5-4BA8-BC03-B27E08876126}" type="datetimeFigureOut">
+            <a:fld id="{1211C29D-6992-4A5E-810C-59ADE211F8AC}" type="datetimeFigureOut">
               <a:rPr lang="en-US" smtClean="0"/>
-              <a:t>5/17/2026</a:t>
+              <a:t>8/26/2026</a:t>
             </a:fld>
             <a:endParaRPr lang="en-US"/>
           </a:p>
@@ -1409,7 +1409,7 @@
           <p:cNvPr id="6" name="Footer Placeholder 5">
             <a:extLst>
               <a:ext uri="{FF2B5EF4-FFF2-40B4-BE49-F238E27FC236}">
-                <a16:creationId xmlns:a16="http://schemas.microsoft.com/office/drawing/2014/main" id="{3540F95C-E0EC-4D24-E6AB-74E188C247DD}"/>
+                <a16:creationId xmlns:a16="http://schemas.microsoft.com/office/drawing/2014/main" id="{AF73E965-9A34-F7C4-D236-AAD0B4129585}"/>
               </a:ext>
             </a:extLst>
           </p:cNvPr>
@@ -1434,7 +1434,7 @@
           <p:cNvPr id="7" name="Slide Number Placeholder 6">
             <a:extLst>
               <a:ext uri="{FF2B5EF4-FFF2-40B4-BE49-F238E27FC236}">
-                <a16:creationId xmlns:a16="http://schemas.microsoft.com/office/drawing/2014/main" id="{F603F9DC-4A41-B7A6-C481-909F6F65F8BC}"/>
+                <a16:creationId xmlns:a16="http://schemas.microsoft.com/office/drawing/2014/main" id="{2F886982-777C-017B-F4AB-2812C80926D5}"/>
               </a:ext>
             </a:extLst>
           </p:cNvPr>
@@ -1450,7 +1450,7 @@
           <a:bodyPr/>
           <a:lstStyle/>
           <a:p>
-            <a:fld id="{3627C499-8D20-466E-8BD2-CC7391BCFA86}" type="slidenum">
+            <a:fld id="{BCBB5E3D-8ABD-442F-B7FD-8616974D6634}" type="slidenum">
               <a:rPr lang="en-US" smtClean="0"/>
               <a:t>‹#›</a:t>
             </a:fld>
@@ -1461,7 +1461,7 @@
     </p:spTree>
     <p:extLst>
       <p:ext uri="{BB962C8B-B14F-4D97-AF65-F5344CB8AC3E}">
-        <p14:creationId xmlns:p14="http://schemas.microsoft.com/office/powerpoint/2010/main" val="3708515932"/>
+        <p14:creationId xmlns:p14="http://schemas.microsoft.com/office/powerpoint/2010/main" val="1534518457"/>
       </p:ext>
     </p:extLst>
   </p:cSld>
@@ -1493,7 +1493,7 @@
           <p:cNvPr id="2" name="Title 1">
             <a:extLst>
               <a:ext uri="{FF2B5EF4-FFF2-40B4-BE49-F238E27FC236}">
-                <a16:creationId xmlns:a16="http://schemas.microsoft.com/office/drawing/2014/main" id="{6CF44740-259C-7EBD-4145-3F8EEF215DA4}"/>
+                <a16:creationId xmlns:a16="http://schemas.microsoft.com/office/drawing/2014/main" id="{D5FB04CD-6AE4-0864-C85D-2CC710C4D438}"/>
               </a:ext>
             </a:extLst>
           </p:cNvPr>
@@ -1526,7 +1526,7 @@
           <p:cNvPr id="3" name="Text Placeholder 2">
             <a:extLst>
               <a:ext uri="{FF2B5EF4-FFF2-40B4-BE49-F238E27FC236}">
-                <a16:creationId xmlns:a16="http://schemas.microsoft.com/office/drawing/2014/main" id="{F48C6A2C-0CE0-BB83-ADD5-E856B44C0FD3}"/>
+                <a16:creationId xmlns:a16="http://schemas.microsoft.com/office/drawing/2014/main" id="{AA9258A1-C9D9-9CC0-5C76-962118933F32}"/>
               </a:ext>
             </a:extLst>
           </p:cNvPr>
@@ -1597,7 +1597,7 @@
           <p:cNvPr id="4" name="Content Placeholder 3">
             <a:extLst>
               <a:ext uri="{FF2B5EF4-FFF2-40B4-BE49-F238E27FC236}">
-                <a16:creationId xmlns:a16="http://schemas.microsoft.com/office/drawing/2014/main" id="{C84D60C3-2313-1E31-A2A3-FC85F6E59573}"/>
+                <a16:creationId xmlns:a16="http://schemas.microsoft.com/office/drawing/2014/main" id="{0532680B-7742-76C3-3885-372EC3BF3FA6}"/>
               </a:ext>
             </a:extLst>
           </p:cNvPr>
@@ -1659,7 +1659,7 @@
           <p:cNvPr id="5" name="Text Placeholder 4">
             <a:extLst>
               <a:ext uri="{FF2B5EF4-FFF2-40B4-BE49-F238E27FC236}">
-                <a16:creationId xmlns:a16="http://schemas.microsoft.com/office/drawing/2014/main" id="{11EE8482-9EAA-17AE-8A48-89D2CA7D509F}"/>
+                <a16:creationId xmlns:a16="http://schemas.microsoft.com/office/drawing/2014/main" id="{AEFF6963-3828-071C-36D5-2E99477FBFB7}"/>
               </a:ext>
             </a:extLst>
           </p:cNvPr>
@@ -1730,7 +1730,7 @@
           <p:cNvPr id="6" name="Content Placeholder 5">
             <a:extLst>
               <a:ext uri="{FF2B5EF4-FFF2-40B4-BE49-F238E27FC236}">
-                <a16:creationId xmlns:a16="http://schemas.microsoft.com/office/drawing/2014/main" id="{FE343C9E-A23E-4848-B44D-C7A7275EF81B}"/>
+                <a16:creationId xmlns:a16="http://schemas.microsoft.com/office/drawing/2014/main" id="{7018CDD5-A1AA-A8EE-B77D-3265B945BAAB}"/>
               </a:ext>
             </a:extLst>
           </p:cNvPr>
@@ -1792,7 +1792,7 @@
           <p:cNvPr id="7" name="Date Placeholder 6">
             <a:extLst>
               <a:ext uri="{FF2B5EF4-FFF2-40B4-BE49-F238E27FC236}">
-                <a16:creationId xmlns:a16="http://schemas.microsoft.com/office/drawing/2014/main" id="{CFCD906D-F85D-D9F1-0043-4BD4C73F86BE}"/>
+                <a16:creationId xmlns:a16="http://schemas.microsoft.com/office/drawing/2014/main" id="{B79E3DCD-17C9-8099-97A0-9EAD7452D04C}"/>
               </a:ext>
             </a:extLst>
           </p:cNvPr>
@@ -1808,9 +1808,9 @@
           <a:bodyPr/>
           <a:lstStyle/>
           <a:p>
-            <a:fld id="{CBFBF2EA-DCA5-4BA8-BC03-B27E08876126}" type="datetimeFigureOut">
+            <a:fld id="{1211C29D-6992-4A5E-810C-59ADE211F8AC}" type="datetimeFigureOut">
               <a:rPr lang="en-US" smtClean="0"/>
-              <a:t>5/17/2026</a:t>
+              <a:t>8/26/2026</a:t>
             </a:fld>
             <a:endParaRPr lang="en-US"/>
           </a:p>
@@ -1821,7 +1821,7 @@
           <p:cNvPr id="8" name="Footer Placeholder 7">
             <a:extLst>
               <a:ext uri="{FF2B5EF4-FFF2-40B4-BE49-F238E27FC236}">
-                <a16:creationId xmlns:a16="http://schemas.microsoft.com/office/drawing/2014/main" id="{FDCBBFBC-4A2A-47FA-5BC5-9A5B9C47C760}"/>
+                <a16:creationId xmlns:a16="http://schemas.microsoft.com/office/drawing/2014/main" id="{C42B4A7E-3720-31F8-6AFE-71F5BE1A293D}"/>
               </a:ext>
             </a:extLst>
           </p:cNvPr>
@@ -1846,7 +1846,7 @@
           <p:cNvPr id="9" name="Slide Number Placeholder 8">
             <a:extLst>
               <a:ext uri="{FF2B5EF4-FFF2-40B4-BE49-F238E27FC236}">
-                <a16:creationId xmlns:a16="http://schemas.microsoft.com/office/drawing/2014/main" id="{8F21AFCC-4F24-8360-1CCE-148E0E841285}"/>
+                <a16:creationId xmlns:a16="http://schemas.microsoft.com/office/drawing/2014/main" id="{8A46044F-02CB-8CC5-3CA6-6D01617077BD}"/>
               </a:ext>
             </a:extLst>
           </p:cNvPr>
@@ -1862,7 +1862,7 @@
           <a:bodyPr/>
           <a:lstStyle/>
           <a:p>
-            <a:fld id="{3627C499-8D20-466E-8BD2-CC7391BCFA86}" type="slidenum">
+            <a:fld id="{BCBB5E3D-8ABD-442F-B7FD-8616974D6634}" type="slidenum">
               <a:rPr lang="en-US" smtClean="0"/>
               <a:t>‹#›</a:t>
             </a:fld>
@@ -1873,7 +1873,7 @@
     </p:spTree>
     <p:extLst>
       <p:ext uri="{BB962C8B-B14F-4D97-AF65-F5344CB8AC3E}">
-        <p14:creationId xmlns:p14="http://schemas.microsoft.com/office/powerpoint/2010/main" val="1856869936"/>
+        <p14:creationId xmlns:p14="http://schemas.microsoft.com/office/powerpoint/2010/main" val="2318556264"/>
       </p:ext>
     </p:extLst>
   </p:cSld>
@@ -1905,7 +1905,7 @@
           <p:cNvPr id="2" name="Title 1">
             <a:extLst>
               <a:ext uri="{FF2B5EF4-FFF2-40B4-BE49-F238E27FC236}">
-                <a16:creationId xmlns:a16="http://schemas.microsoft.com/office/drawing/2014/main" id="{054C18DC-45D1-9521-E872-7AAAF41F3D5E}"/>
+                <a16:creationId xmlns:a16="http://schemas.microsoft.com/office/drawing/2014/main" id="{AC1F8BB6-59BF-1041-5D78-74346A7AF190}"/>
               </a:ext>
             </a:extLst>
           </p:cNvPr>
@@ -1933,7 +1933,7 @@
           <p:cNvPr id="3" name="Date Placeholder 2">
             <a:extLst>
               <a:ext uri="{FF2B5EF4-FFF2-40B4-BE49-F238E27FC236}">
-                <a16:creationId xmlns:a16="http://schemas.microsoft.com/office/drawing/2014/main" id="{E6844C03-175A-3D4B-A0D8-947155CBCFFC}"/>
+                <a16:creationId xmlns:a16="http://schemas.microsoft.com/office/drawing/2014/main" id="{F834DB58-D334-6279-AE96-1FF383EEFF3A}"/>
               </a:ext>
             </a:extLst>
           </p:cNvPr>
@@ -1949,9 +1949,9 @@
           <a:bodyPr/>
           <a:lstStyle/>
           <a:p>
-            <a:fld id="{CBFBF2EA-DCA5-4BA8-BC03-B27E08876126}" type="datetimeFigureOut">
+            <a:fld id="{1211C29D-6992-4A5E-810C-59ADE211F8AC}" type="datetimeFigureOut">
               <a:rPr lang="en-US" smtClean="0"/>
-              <a:t>5/17/2026</a:t>
+              <a:t>8/26/2026</a:t>
             </a:fld>
             <a:endParaRPr lang="en-US"/>
           </a:p>
@@ -1962,7 +1962,7 @@
           <p:cNvPr id="4" name="Footer Placeholder 3">
             <a:extLst>
               <a:ext uri="{FF2B5EF4-FFF2-40B4-BE49-F238E27FC236}">
-                <a16:creationId xmlns:a16="http://schemas.microsoft.com/office/drawing/2014/main" id="{9D4E4DA1-E568-6F6B-0B18-713E9A17157D}"/>
+                <a16:creationId xmlns:a16="http://schemas.microsoft.com/office/drawing/2014/main" id="{706322E0-ABBF-1E38-54FC-373693A18233}"/>
               </a:ext>
             </a:extLst>
           </p:cNvPr>
@@ -1987,7 +1987,7 @@
           <p:cNvPr id="5" name="Slide Number Placeholder 4">
             <a:extLst>
               <a:ext uri="{FF2B5EF4-FFF2-40B4-BE49-F238E27FC236}">
-                <a16:creationId xmlns:a16="http://schemas.microsoft.com/office/drawing/2014/main" id="{FC043214-E886-5227-F364-931C5FC20974}"/>
+                <a16:creationId xmlns:a16="http://schemas.microsoft.com/office/drawing/2014/main" id="{D2A4E592-EB76-485C-39D9-242BAC510C0F}"/>
               </a:ext>
             </a:extLst>
           </p:cNvPr>
@@ -2003,7 +2003,7 @@
           <a:bodyPr/>
           <a:lstStyle/>
           <a:p>
-            <a:fld id="{3627C499-8D20-466E-8BD2-CC7391BCFA86}" type="slidenum">
+            <a:fld id="{BCBB5E3D-8ABD-442F-B7FD-8616974D6634}" type="slidenum">
               <a:rPr lang="en-US" smtClean="0"/>
               <a:t>‹#›</a:t>
             </a:fld>
@@ -2014,7 +2014,7 @@
     </p:spTree>
     <p:extLst>
       <p:ext uri="{BB962C8B-B14F-4D97-AF65-F5344CB8AC3E}">
-        <p14:creationId xmlns:p14="http://schemas.microsoft.com/office/powerpoint/2010/main" val="2019301324"/>
+        <p14:creationId xmlns:p14="http://schemas.microsoft.com/office/powerpoint/2010/main" val="3009980954"/>
       </p:ext>
     </p:extLst>
   </p:cSld>
@@ -2046,7 +2046,7 @@
           <p:cNvPr id="2" name="Date Placeholder 1">
             <a:extLst>
               <a:ext uri="{FF2B5EF4-FFF2-40B4-BE49-F238E27FC236}">
-                <a16:creationId xmlns:a16="http://schemas.microsoft.com/office/drawing/2014/main" id="{35CC6EF0-CB4E-B8A4-F7D5-3BAAF992226E}"/>
+                <a16:creationId xmlns:a16="http://schemas.microsoft.com/office/drawing/2014/main" id="{DAE41CF7-6337-5506-A16F-6DBC8C7ED8DC}"/>
               </a:ext>
             </a:extLst>
           </p:cNvPr>
@@ -2062,9 +2062,9 @@
           <a:bodyPr/>
           <a:lstStyle/>
           <a:p>
-            <a:fld id="{CBFBF2EA-DCA5-4BA8-BC03-B27E08876126}" type="datetimeFigureOut">
+            <a:fld id="{1211C29D-6992-4A5E-810C-59ADE211F8AC}" type="datetimeFigureOut">
               <a:rPr lang="en-US" smtClean="0"/>
-              <a:t>5/17/2026</a:t>
+              <a:t>8/26/2026</a:t>
             </a:fld>
             <a:endParaRPr lang="en-US"/>
           </a:p>
@@ -2075,7 +2075,7 @@
           <p:cNvPr id="3" name="Footer Placeholder 2">
             <a:extLst>
               <a:ext uri="{FF2B5EF4-FFF2-40B4-BE49-F238E27FC236}">
-                <a16:creationId xmlns:a16="http://schemas.microsoft.com/office/drawing/2014/main" id="{517C08A1-7A21-A673-38B4-1F10E8478D11}"/>
+                <a16:creationId xmlns:a16="http://schemas.microsoft.com/office/drawing/2014/main" id="{916BF36B-334F-D5D6-E7B5-E172BD4A54D3}"/>
               </a:ext>
             </a:extLst>
           </p:cNvPr>
@@ -2100,7 +2100,7 @@
           <p:cNvPr id="4" name="Slide Number Placeholder 3">
             <a:extLst>
               <a:ext uri="{FF2B5EF4-FFF2-40B4-BE49-F238E27FC236}">
-                <a16:creationId xmlns:a16="http://schemas.microsoft.com/office/drawing/2014/main" id="{2E6A02A2-38DB-0CBA-7352-B5BEAAA5538C}"/>
+                <a16:creationId xmlns:a16="http://schemas.microsoft.com/office/drawing/2014/main" id="{94F32512-2CDB-D7EE-F99A-07FCBBDF215F}"/>
               </a:ext>
             </a:extLst>
           </p:cNvPr>
@@ -2116,7 +2116,7 @@
           <a:bodyPr/>
           <a:lstStyle/>
           <a:p>
-            <a:fld id="{3627C499-8D20-466E-8BD2-CC7391BCFA86}" type="slidenum">
+            <a:fld id="{BCBB5E3D-8ABD-442F-B7FD-8616974D6634}" type="slidenum">
               <a:rPr lang="en-US" smtClean="0"/>
               <a:t>‹#›</a:t>
             </a:fld>
@@ -2127,7 +2127,7 @@
     </p:spTree>
     <p:extLst>
       <p:ext uri="{BB962C8B-B14F-4D97-AF65-F5344CB8AC3E}">
-        <p14:creationId xmlns:p14="http://schemas.microsoft.com/office/powerpoint/2010/main" val="3445183269"/>
+        <p14:creationId xmlns:p14="http://schemas.microsoft.com/office/powerpoint/2010/main" val="2571965475"/>
       </p:ext>
     </p:extLst>
   </p:cSld>
@@ -2159,7 +2159,7 @@
           <p:cNvPr id="2" name="Title 1">
             <a:extLst>
               <a:ext uri="{FF2B5EF4-FFF2-40B4-BE49-F238E27FC236}">
-                <a16:creationId xmlns:a16="http://schemas.microsoft.com/office/drawing/2014/main" id="{7318DBAC-80D4-EECD-C743-723C11094B4C}"/>
+                <a16:creationId xmlns:a16="http://schemas.microsoft.com/office/drawing/2014/main" id="{9A11E832-8717-61E2-0444-C267505275F0}"/>
               </a:ext>
             </a:extLst>
           </p:cNvPr>
@@ -2196,7 +2196,7 @@
           <p:cNvPr id="3" name="Content Placeholder 2">
             <a:extLst>
               <a:ext uri="{FF2B5EF4-FFF2-40B4-BE49-F238E27FC236}">
-                <a16:creationId xmlns:a16="http://schemas.microsoft.com/office/drawing/2014/main" id="{263868BF-E5CA-1822-EC22-635D8D41E501}"/>
+                <a16:creationId xmlns:a16="http://schemas.microsoft.com/office/drawing/2014/main" id="{6E9205BC-19A5-0CBF-BA59-F01B7DD71093}"/>
               </a:ext>
             </a:extLst>
           </p:cNvPr>
@@ -2286,7 +2286,7 @@
           <p:cNvPr id="4" name="Text Placeholder 3">
             <a:extLst>
               <a:ext uri="{FF2B5EF4-FFF2-40B4-BE49-F238E27FC236}">
-                <a16:creationId xmlns:a16="http://schemas.microsoft.com/office/drawing/2014/main" id="{2C5D33F2-2812-AFC7-7B83-7130B2F1DAD6}"/>
+                <a16:creationId xmlns:a16="http://schemas.microsoft.com/office/drawing/2014/main" id="{2724EC3F-56ED-0C21-5D38-1FB5FF1C9591}"/>
               </a:ext>
             </a:extLst>
           </p:cNvPr>
@@ -2357,7 +2357,7 @@
           <p:cNvPr id="5" name="Date Placeholder 4">
             <a:extLst>
               <a:ext uri="{FF2B5EF4-FFF2-40B4-BE49-F238E27FC236}">
-                <a16:creationId xmlns:a16="http://schemas.microsoft.com/office/drawing/2014/main" id="{92719DB1-B0FA-A55A-DF94-0DB1DC7000C4}"/>
+                <a16:creationId xmlns:a16="http://schemas.microsoft.com/office/drawing/2014/main" id="{7C483F0E-EB61-23A7-E526-E7F579E54745}"/>
               </a:ext>
             </a:extLst>
           </p:cNvPr>
@@ -2373,9 +2373,9 @@
           <a:bodyPr/>
           <a:lstStyle/>
           <a:p>
-            <a:fld id="{CBFBF2EA-DCA5-4BA8-BC03-B27E08876126}" type="datetimeFigureOut">
+            <a:fld id="{1211C29D-6992-4A5E-810C-59ADE211F8AC}" type="datetimeFigureOut">
               <a:rPr lang="en-US" smtClean="0"/>
-              <a:t>5/17/2026</a:t>
+              <a:t>8/26/2026</a:t>
             </a:fld>
             <a:endParaRPr lang="en-US"/>
           </a:p>
@@ -2386,7 +2386,7 @@
           <p:cNvPr id="6" name="Footer Placeholder 5">
             <a:extLst>
               <a:ext uri="{FF2B5EF4-FFF2-40B4-BE49-F238E27FC236}">
-                <a16:creationId xmlns:a16="http://schemas.microsoft.com/office/drawing/2014/main" id="{BCD90734-A729-147F-4AFD-24941553A128}"/>
+                <a16:creationId xmlns:a16="http://schemas.microsoft.com/office/drawing/2014/main" id="{A1EA26D6-C4BA-2FE5-2C2B-B406BC641BA0}"/>
               </a:ext>
             </a:extLst>
           </p:cNvPr>
@@ -2411,7 +2411,7 @@
           <p:cNvPr id="7" name="Slide Number Placeholder 6">
             <a:extLst>
               <a:ext uri="{FF2B5EF4-FFF2-40B4-BE49-F238E27FC236}">
-                <a16:creationId xmlns:a16="http://schemas.microsoft.com/office/drawing/2014/main" id="{47F0ADBE-4D14-83CE-913F-BA5B1D98F9AF}"/>
+                <a16:creationId xmlns:a16="http://schemas.microsoft.com/office/drawing/2014/main" id="{25F15092-DD70-39FE-8C3C-A89D6FB95232}"/>
               </a:ext>
             </a:extLst>
           </p:cNvPr>
@@ -2427,7 +2427,7 @@
           <a:bodyPr/>
           <a:lstStyle/>
           <a:p>
-            <a:fld id="{3627C499-8D20-466E-8BD2-CC7391BCFA86}" type="slidenum">
+            <a:fld id="{BCBB5E3D-8ABD-442F-B7FD-8616974D6634}" type="slidenum">
               <a:rPr lang="en-US" smtClean="0"/>
               <a:t>‹#›</a:t>
             </a:fld>
@@ -2438,7 +2438,7 @@
     </p:spTree>
     <p:extLst>
       <p:ext uri="{BB962C8B-B14F-4D97-AF65-F5344CB8AC3E}">
-        <p14:creationId xmlns:p14="http://schemas.microsoft.com/office/powerpoint/2010/main" val="657629408"/>
+        <p14:creationId xmlns:p14="http://schemas.microsoft.com/office/powerpoint/2010/main" val="1573282232"/>
       </p:ext>
     </p:extLst>
   </p:cSld>
@@ -2470,7 +2470,7 @@
           <p:cNvPr id="2" name="Title 1">
             <a:extLst>
               <a:ext uri="{FF2B5EF4-FFF2-40B4-BE49-F238E27FC236}">
-                <a16:creationId xmlns:a16="http://schemas.microsoft.com/office/drawing/2014/main" id="{B6325B74-B860-B4D7-7889-65C92346CDA0}"/>
+                <a16:creationId xmlns:a16="http://schemas.microsoft.com/office/drawing/2014/main" id="{F2B650CE-C62B-1D08-6CF7-81FDACED3682}"/>
               </a:ext>
             </a:extLst>
           </p:cNvPr>
@@ -2507,7 +2507,7 @@
           <p:cNvPr id="3" name="Picture Placeholder 2">
             <a:extLst>
               <a:ext uri="{FF2B5EF4-FFF2-40B4-BE49-F238E27FC236}">
-                <a16:creationId xmlns:a16="http://schemas.microsoft.com/office/drawing/2014/main" id="{08BDCCED-4AF0-8D2E-ECBC-F7C531CE4895}"/>
+                <a16:creationId xmlns:a16="http://schemas.microsoft.com/office/drawing/2014/main" id="{20989828-704E-6286-A0CD-CB3CDFBAD0B5}"/>
               </a:ext>
             </a:extLst>
           </p:cNvPr>
@@ -2574,7 +2574,7 @@
           <p:cNvPr id="4" name="Text Placeholder 3">
             <a:extLst>
               <a:ext uri="{FF2B5EF4-FFF2-40B4-BE49-F238E27FC236}">
-                <a16:creationId xmlns:a16="http://schemas.microsoft.com/office/drawing/2014/main" id="{BC61FBD8-0F26-186E-2B11-B11BA317D2ED}"/>
+                <a16:creationId xmlns:a16="http://schemas.microsoft.com/office/drawing/2014/main" id="{12885135-83ED-847F-4FDA-96EE5A180B3D}"/>
               </a:ext>
             </a:extLst>
           </p:cNvPr>
@@ -2645,7 +2645,7 @@
           <p:cNvPr id="5" name="Date Placeholder 4">
             <a:extLst>
               <a:ext uri="{FF2B5EF4-FFF2-40B4-BE49-F238E27FC236}">
-                <a16:creationId xmlns:a16="http://schemas.microsoft.com/office/drawing/2014/main" id="{BD8360FA-B100-EDB8-9DB3-46B8830FA0AF}"/>
+                <a16:creationId xmlns:a16="http://schemas.microsoft.com/office/drawing/2014/main" id="{6CADA230-BB58-5295-69C9-20A0D99D00EB}"/>
               </a:ext>
             </a:extLst>
           </p:cNvPr>
@@ -2661,9 +2661,9 @@
           <a:bodyPr/>
           <a:lstStyle/>
           <a:p>
-            <a:fld id="{CBFBF2EA-DCA5-4BA8-BC03-B27E08876126}" type="datetimeFigureOut">
+            <a:fld id="{1211C29D-6992-4A5E-810C-59ADE211F8AC}" type="datetimeFigureOut">
               <a:rPr lang="en-US" smtClean="0"/>
-              <a:t>5/17/2026</a:t>
+              <a:t>8/26/2026</a:t>
             </a:fld>
             <a:endParaRPr lang="en-US"/>
           </a:p>
@@ -2674,7 +2674,7 @@
           <p:cNvPr id="6" name="Footer Placeholder 5">
             <a:extLst>
               <a:ext uri="{FF2B5EF4-FFF2-40B4-BE49-F238E27FC236}">
-                <a16:creationId xmlns:a16="http://schemas.microsoft.com/office/drawing/2014/main" id="{576BE76A-8481-08B4-519A-1400FD54BB61}"/>
+                <a16:creationId xmlns:a16="http://schemas.microsoft.com/office/drawing/2014/main" id="{46A6ACB7-24C0-7E91-F04A-C8A0D286A092}"/>
               </a:ext>
             </a:extLst>
           </p:cNvPr>
@@ -2699,7 +2699,7 @@
           <p:cNvPr id="7" name="Slide Number Placeholder 6">
             <a:extLst>
               <a:ext uri="{FF2B5EF4-FFF2-40B4-BE49-F238E27FC236}">
-                <a16:creationId xmlns:a16="http://schemas.microsoft.com/office/drawing/2014/main" id="{23BD036F-40DC-6B2F-94A5-097AE411CF8C}"/>
+                <a16:creationId xmlns:a16="http://schemas.microsoft.com/office/drawing/2014/main" id="{B8D36AB1-F722-B3EE-19ED-59F32F4FB6D7}"/>
               </a:ext>
             </a:extLst>
           </p:cNvPr>
@@ -2715,7 +2715,7 @@
           <a:bodyPr/>
           <a:lstStyle/>
           <a:p>
-            <a:fld id="{3627C499-8D20-466E-8BD2-CC7391BCFA86}" type="slidenum">
+            <a:fld id="{BCBB5E3D-8ABD-442F-B7FD-8616974D6634}" type="slidenum">
               <a:rPr lang="en-US" smtClean="0"/>
               <a:t>‹#›</a:t>
             </a:fld>
@@ -2726,7 +2726,7 @@
     </p:spTree>
     <p:extLst>
       <p:ext uri="{BB962C8B-B14F-4D97-AF65-F5344CB8AC3E}">
-        <p14:creationId xmlns:p14="http://schemas.microsoft.com/office/powerpoint/2010/main" val="4268486611"/>
+        <p14:creationId xmlns:p14="http://schemas.microsoft.com/office/powerpoint/2010/main" val="2546970579"/>
       </p:ext>
     </p:extLst>
   </p:cSld>
@@ -2763,7 +2763,7 @@
           <p:cNvPr id="2" name="Title Placeholder 1">
             <a:extLst>
               <a:ext uri="{FF2B5EF4-FFF2-40B4-BE49-F238E27FC236}">
-                <a16:creationId xmlns:a16="http://schemas.microsoft.com/office/drawing/2014/main" id="{7816332C-725E-A077-0F9D-D3FA50292A50}"/>
+                <a16:creationId xmlns:a16="http://schemas.microsoft.com/office/drawing/2014/main" id="{EB4411E5-DABF-3356-B0F1-32EA6965CAB9}"/>
               </a:ext>
             </a:extLst>
           </p:cNvPr>
@@ -2801,7 +2801,7 @@
           <p:cNvPr id="3" name="Text Placeholder 2">
             <a:extLst>
               <a:ext uri="{FF2B5EF4-FFF2-40B4-BE49-F238E27FC236}">
-                <a16:creationId xmlns:a16="http://schemas.microsoft.com/office/drawing/2014/main" id="{F41D85DD-9566-12CB-100B-E383B51477CF}"/>
+                <a16:creationId xmlns:a16="http://schemas.microsoft.com/office/drawing/2014/main" id="{CC2AA1D2-25CD-D577-CCD5-459150F7E9E1}"/>
               </a:ext>
             </a:extLst>
           </p:cNvPr>
@@ -2868,7 +2868,7 @@
           <p:cNvPr id="4" name="Date Placeholder 3">
             <a:extLst>
               <a:ext uri="{FF2B5EF4-FFF2-40B4-BE49-F238E27FC236}">
-                <a16:creationId xmlns:a16="http://schemas.microsoft.com/office/drawing/2014/main" id="{6A3B2107-9550-12C3-DF0F-262C421399F2}"/>
+                <a16:creationId xmlns:a16="http://schemas.microsoft.com/office/drawing/2014/main" id="{C74C7709-E617-6C9D-F204-0738CF161E2B}"/>
               </a:ext>
             </a:extLst>
           </p:cNvPr>
@@ -2902,9 +2902,9 @@
             </a:lvl1pPr>
           </a:lstStyle>
           <a:p>
-            <a:fld id="{CBFBF2EA-DCA5-4BA8-BC03-B27E08876126}" type="datetimeFigureOut">
+            <a:fld id="{1211C29D-6992-4A5E-810C-59ADE211F8AC}" type="datetimeFigureOut">
               <a:rPr lang="en-US" smtClean="0"/>
-              <a:t>5/17/2026</a:t>
+              <a:t>8/26/2026</a:t>
             </a:fld>
             <a:endParaRPr lang="en-US"/>
           </a:p>
@@ -2915,7 +2915,7 @@
           <p:cNvPr id="5" name="Footer Placeholder 4">
             <a:extLst>
               <a:ext uri="{FF2B5EF4-FFF2-40B4-BE49-F238E27FC236}">
-                <a16:creationId xmlns:a16="http://schemas.microsoft.com/office/drawing/2014/main" id="{024D7699-4DEA-E741-3E79-67025D72E959}"/>
+                <a16:creationId xmlns:a16="http://schemas.microsoft.com/office/drawing/2014/main" id="{F559D974-1758-E605-6012-0C24D4C12F3C}"/>
               </a:ext>
             </a:extLst>
           </p:cNvPr>
@@ -2958,7 +2958,7 @@
           <p:cNvPr id="6" name="Slide Number Placeholder 5">
             <a:extLst>
               <a:ext uri="{FF2B5EF4-FFF2-40B4-BE49-F238E27FC236}">
-                <a16:creationId xmlns:a16="http://schemas.microsoft.com/office/drawing/2014/main" id="{D0EA8D6F-E027-98CD-1FFD-777F66776ABD}"/>
+                <a16:creationId xmlns:a16="http://schemas.microsoft.com/office/drawing/2014/main" id="{C2D5C42B-F832-6C88-61C0-BB864A841D9A}"/>
               </a:ext>
             </a:extLst>
           </p:cNvPr>
@@ -2992,7 +2992,7 @@
             </a:lvl1pPr>
           </a:lstStyle>
           <a:p>
-            <a:fld id="{3627C499-8D20-466E-8BD2-CC7391BCFA86}" type="slidenum">
+            <a:fld id="{BCBB5E3D-8ABD-442F-B7FD-8616974D6634}" type="slidenum">
               <a:rPr lang="en-US" smtClean="0"/>
               <a:t>‹#›</a:t>
             </a:fld>
@@ -3003,7 +3003,7 @@
     </p:spTree>
     <p:extLst>
       <p:ext uri="{BB962C8B-B14F-4D97-AF65-F5344CB8AC3E}">
-        <p14:creationId xmlns:p14="http://schemas.microsoft.com/office/powerpoint/2010/main" val="2161997589"/>
+        <p14:creationId xmlns:p14="http://schemas.microsoft.com/office/powerpoint/2010/main" val="3862751293"/>
       </p:ext>
     </p:extLst>
   </p:cSld>
@@ -3326,7 +3326,7 @@
           <p:cNvPr id="2" name="Title 1">
             <a:extLst>
               <a:ext uri="{FF2B5EF4-FFF2-40B4-BE49-F238E27FC236}">
-                <a16:creationId xmlns:a16="http://schemas.microsoft.com/office/drawing/2014/main" id="{F08F2F19-F343-0925-90A5-853E1C5C51BB}"/>
+                <a16:creationId xmlns:a16="http://schemas.microsoft.com/office/drawing/2014/main" id="{38EB3BAC-457F-C24A-6377-F06D1D45F78D}"/>
               </a:ext>
             </a:extLst>
           </p:cNvPr>
@@ -3354,7 +3354,7 @@
           <p:cNvPr id="3" name="Content Placeholder 2">
             <a:extLst>
               <a:ext uri="{FF2B5EF4-FFF2-40B4-BE49-F238E27FC236}">
-                <a16:creationId xmlns:a16="http://schemas.microsoft.com/office/drawing/2014/main" id="{7786A774-C085-F3CF-0DFB-52CB6372C0EF}"/>
+                <a16:creationId xmlns:a16="http://schemas.microsoft.com/office/drawing/2014/main" id="{1ADA4453-C417-3DAE-E0C1-7A6D6F5CB561}"/>
               </a:ext>
             </a:extLst>
           </p:cNvPr>
@@ -3377,7 +3377,7 @@
     </p:spTree>
     <p:extLst>
       <p:ext uri="{BB962C8B-B14F-4D97-AF65-F5344CB8AC3E}">
-        <p14:creationId xmlns:p14="http://schemas.microsoft.com/office/powerpoint/2010/main" val="563397346"/>
+        <p14:creationId xmlns:p14="http://schemas.microsoft.com/office/powerpoint/2010/main" val="3116676319"/>
       </p:ext>
     </p:extLst>
   </p:cSld>

</xml_diff>